<commit_message>
SCRNA: automatic work clean-up after successful runs (--keep_work); translate docs to English
</commit_message>
<xml_diff>
--- a/SCRNA/scRNAseq_QC_pipeline/docs/scrnaseq_qc_pipeline_diagram_editable.pptx
+++ b/SCRNA/scRNAseq_QC_pipeline/docs/scrnaseq_qc_pipeline_diagram_editable.pptx
@@ -120,7 +120,7 @@
           <a:lstStyle/>
           <a:p>
             <a:r>
-              <a:rPr lang="ko-KR" sz="2600" b="1">
+              <a:rPr lang="en-US" sz="2600" b="1">
                 <a:solidFill>
                   <a:srgbClr val="1F2937"/>
                 </a:solidFill>
@@ -129,11 +129,11 @@
               </a:rPr>
               <a:t>K_map scRNA-seq Preprocessing and QC Pipeline</a:t>
             </a:r>
-            <a:endParaRPr lang="ko-KR" sz="2600"/>
-          </a:p>
-          <a:p>
-            <a:r>
-              <a:rPr lang="ko-KR" sz="1400">
+            <a:endParaRPr lang="en-US" sz="2600"/>
+          </a:p>
+          <a:p>
+            <a:r>
+              <a:rPr lang="en-US" sz="1400">
                 <a:solidFill>
                   <a:srgbClr val="4B5563"/>
                 </a:solidFill>
@@ -142,7 +142,7 @@
               </a:rPr>
               <a:t>Cell Ranger SIF + CellBender + Scanpy QC + SOLO doublet filtering</a:t>
             </a:r>
-            <a:endParaRPr lang="ko-KR" sz="1400"/>
+            <a:endParaRPr lang="en-US" sz="1400"/>
           </a:p>
         </p:txBody>
       </p:sp>
@@ -268,7 +268,7 @@
           <a:lstStyle/>
           <a:p>
             <a:r>
-              <a:rPr lang="ko-KR" sz="1100">
+              <a:rPr lang="en-US" sz="1100">
                 <a:solidFill>
                   <a:srgbClr val="374151"/>
                 </a:solidFill>
@@ -277,7 +277,7 @@
               </a:rPr>
               <a:t>Pipeline step</a:t>
             </a:r>
-            <a:endParaRPr lang="ko-KR" sz="1100"/>
+            <a:endParaRPr lang="en-US" sz="1100"/>
           </a:p>
         </p:txBody>
       </p:sp>
@@ -379,7 +379,7 @@
           <a:lstStyle/>
           <a:p>
             <a:r>
-              <a:rPr lang="ko-KR" sz="1100">
+              <a:rPr lang="en-US" sz="1100">
                 <a:solidFill>
                   <a:srgbClr val="374151"/>
                 </a:solidFill>
@@ -388,7 +388,7 @@
               </a:rPr>
               <a:t>Final output</a:t>
             </a:r>
-            <a:endParaRPr lang="ko-KR" sz="1100"/>
+            <a:endParaRPr lang="en-US" sz="1100"/>
           </a:p>
         </p:txBody>
       </p:sp>
@@ -490,7 +490,7 @@
           <a:lstStyle/>
           <a:p>
             <a:r>
-              <a:rPr lang="ko-KR" sz="1100">
+              <a:rPr lang="en-US" sz="1100">
                 <a:solidFill>
                   <a:srgbClr val="374151"/>
                 </a:solidFill>
@@ -499,7 +499,7 @@
               </a:rPr>
               <a:t>Input / reference</a:t>
             </a:r>
-            <a:endParaRPr lang="ko-KR" sz="1100"/>
+            <a:endParaRPr lang="en-US" sz="1100"/>
           </a:p>
         </p:txBody>
       </p:sp>
@@ -554,7 +554,7 @@
           <a:lstStyle/>
           <a:p>
             <a:r>
-              <a:rPr lang="ko-KR" sz="1100">
+              <a:rPr lang="en-US" sz="1100">
                 <a:solidFill>
                   <a:srgbClr val="374151"/>
                 </a:solidFill>
@@ -563,7 +563,7 @@
               </a:rPr>
               <a:t>Optional start point</a:t>
             </a:r>
-            <a:endParaRPr lang="ko-KR" sz="1100"/>
+            <a:endParaRPr lang="en-US" sz="1100"/>
           </a:p>
         </p:txBody>
       </p:sp>
@@ -639,7 +639,7 @@
           <a:lstStyle/>
           <a:p>
             <a:r>
-              <a:rPr lang="ko-KR" sz="1300" b="1">
+              <a:rPr lang="en-US" sz="1300" b="1">
                 <a:solidFill>
                   <a:srgbClr val="0F766E"/>
                 </a:solidFill>
@@ -648,11 +648,11 @@
               </a:rPr>
               <a:t>00</a:t>
             </a:r>
-            <a:endParaRPr lang="ko-KR" sz="1300"/>
-          </a:p>
-          <a:p>
-            <a:r>
-              <a:rPr lang="ko-KR" sz="1600" b="1">
+            <a:endParaRPr lang="en-US" sz="1300"/>
+          </a:p>
+          <a:p>
+            <a:r>
+              <a:rPr lang="en-US" sz="1600" b="1">
                 <a:solidFill>
                   <a:srgbClr val="111827"/>
                 </a:solidFill>
@@ -661,11 +661,11 @@
               </a:rPr>
               <a:t>FASTQ directory</a:t>
             </a:r>
-            <a:endParaRPr lang="ko-KR" sz="1600"/>
-          </a:p>
-          <a:p>
-            <a:r>
-              <a:rPr lang="ko-KR" sz="1300">
+            <a:endParaRPr lang="en-US" sz="1600"/>
+          </a:p>
+          <a:p>
+            <a:r>
+              <a:rPr lang="en-US" sz="1300">
                 <a:solidFill>
                   <a:srgbClr val="374151"/>
                 </a:solidFill>
@@ -674,7 +674,7 @@
               </a:rPr>
               <a:t>sample_R1/R2/I1/I2 fastq.gz</a:t>
             </a:r>
-            <a:endParaRPr lang="ko-KR" sz="1300"/>
+            <a:endParaRPr lang="en-US" sz="1300"/>
           </a:p>
         </p:txBody>
       </p:sp>
@@ -728,7 +728,7 @@
           <a:lstStyle/>
           <a:p>
             <a:r>
-              <a:rPr lang="ko-KR" sz="1200" b="1">
+              <a:rPr lang="en-US" sz="1200" b="1">
                 <a:solidFill>
                   <a:srgbClr val="374151"/>
                 </a:solidFill>
@@ -737,7 +737,7 @@
               </a:rPr>
               <a:t>cellranger</a:t>
             </a:r>
-            <a:endParaRPr lang="ko-KR" sz="1200"/>
+            <a:endParaRPr lang="en-US" sz="1200"/>
           </a:p>
         </p:txBody>
       </p:sp>
@@ -835,7 +835,7 @@
           <a:lstStyle/>
           <a:p>
             <a:r>
-              <a:rPr lang="ko-KR" sz="1600" b="1">
+              <a:rPr lang="en-US" sz="1600" b="1">
                 <a:solidFill>
                   <a:srgbClr val="111827"/>
                 </a:solidFill>
@@ -844,11 +844,11 @@
               </a:rPr>
               <a:t>10x Reference</a:t>
             </a:r>
-            <a:endParaRPr lang="ko-KR" sz="1600"/>
-          </a:p>
-          <a:p>
-            <a:r>
-              <a:rPr lang="ko-KR" sz="1300">
+            <a:endParaRPr lang="en-US" sz="1600"/>
+          </a:p>
+          <a:p>
+            <a:r>
+              <a:rPr lang="en-US" sz="1300">
                 <a:solidFill>
                   <a:srgbClr val="374151"/>
                 </a:solidFill>
@@ -857,11 +857,11 @@
               </a:rPr>
               <a:t>User supplied transcriptome</a:t>
             </a:r>
-            <a:endParaRPr lang="ko-KR" sz="1300"/>
-          </a:p>
-          <a:p>
-            <a:r>
-              <a:rPr lang="ko-KR" sz="1300">
+            <a:endParaRPr lang="en-US" sz="1300"/>
+          </a:p>
+          <a:p>
+            <a:r>
+              <a:rPr lang="en-US" sz="1300">
                 <a:solidFill>
                   <a:srgbClr val="374151"/>
                 </a:solidFill>
@@ -870,7 +870,7 @@
               </a:rPr>
               <a:t>refdata-gex-GRCm39/GRCh38</a:t>
             </a:r>
-            <a:endParaRPr lang="ko-KR" sz="1300"/>
+            <a:endParaRPr lang="en-US" sz="1300"/>
           </a:p>
         </p:txBody>
       </p:sp>
@@ -968,7 +968,7 @@
           <a:lstStyle/>
           <a:p>
             <a:r>
-              <a:rPr lang="ko-KR" sz="1300" b="1">
+              <a:rPr lang="en-US" sz="1300" b="1">
                 <a:solidFill>
                   <a:srgbClr val="0F766E"/>
                 </a:solidFill>
@@ -977,11 +977,11 @@
               </a:rPr>
               <a:t>01</a:t>
             </a:r>
-            <a:endParaRPr lang="ko-KR" sz="1300"/>
-          </a:p>
-          <a:p>
-            <a:r>
-              <a:rPr lang="ko-KR" sz="1600" b="1">
+            <a:endParaRPr lang="en-US" sz="1300"/>
+          </a:p>
+          <a:p>
+            <a:r>
+              <a:rPr lang="en-US" sz="1600" b="1">
                 <a:solidFill>
                   <a:srgbClr val="111827"/>
                 </a:solidFill>
@@ -990,11 +990,11 @@
               </a:rPr>
               <a:t>Cell Ranger Count</a:t>
             </a:r>
-            <a:endParaRPr lang="ko-KR" sz="1600"/>
-          </a:p>
-          <a:p>
-            <a:r>
-              <a:rPr lang="ko-KR" sz="1300">
+            <a:endParaRPr lang="en-US" sz="1600"/>
+          </a:p>
+          <a:p>
+            <a:r>
+              <a:rPr lang="en-US" sz="1300">
                 <a:solidFill>
                   <a:srgbClr val="374151"/>
                 </a:solidFill>
@@ -1003,11 +1003,11 @@
               </a:rPr>
               <a:t>raw_feature_bc_matrix.h5</a:t>
             </a:r>
-            <a:endParaRPr lang="ko-KR" sz="1300"/>
-          </a:p>
-          <a:p>
-            <a:r>
-              <a:rPr lang="ko-KR" sz="1300">
+            <a:endParaRPr lang="en-US" sz="1300"/>
+          </a:p>
+          <a:p>
+            <a:r>
+              <a:rPr lang="en-US" sz="1300">
                 <a:solidFill>
                   <a:srgbClr val="374151"/>
                 </a:solidFill>
@@ -1016,7 +1016,7 @@
               </a:rPr>
               <a:t>filtered matrix, metrics, web summary</a:t>
             </a:r>
-            <a:endParaRPr lang="ko-KR" sz="1300"/>
+            <a:endParaRPr lang="en-US" sz="1300"/>
           </a:p>
         </p:txBody>
       </p:sp>
@@ -1070,7 +1070,7 @@
           <a:lstStyle/>
           <a:p>
             <a:r>
-              <a:rPr lang="ko-KR" sz="1200" b="1">
+              <a:rPr lang="en-US" sz="1200" b="1">
                 <a:solidFill>
                   <a:srgbClr val="374151"/>
                 </a:solidFill>
@@ -1079,7 +1079,7 @@
               </a:rPr>
               <a:t>CellBender</a:t>
             </a:r>
-            <a:endParaRPr lang="ko-KR" sz="1200"/>
+            <a:endParaRPr lang="en-US" sz="1200"/>
           </a:p>
         </p:txBody>
       </p:sp>
@@ -1156,7 +1156,7 @@
           <a:lstStyle/>
           <a:p>
             <a:r>
-              <a:rPr lang="ko-KR" sz="1600" b="1">
+              <a:rPr lang="en-US" sz="1600" b="1">
                 <a:solidFill>
                   <a:srgbClr val="111827"/>
                 </a:solidFill>
@@ -1165,11 +1165,11 @@
               </a:rPr>
               <a:t>Optional start: raw_h5</a:t>
             </a:r>
-            <a:endParaRPr lang="ko-KR" sz="1600"/>
-          </a:p>
-          <a:p>
-            <a:r>
-              <a:rPr lang="ko-KR" sz="1300">
+            <a:endParaRPr lang="en-US" sz="1600"/>
+          </a:p>
+          <a:p>
+            <a:r>
+              <a:rPr lang="en-US" sz="1300">
                 <a:solidFill>
                   <a:srgbClr val="374151"/>
                 </a:solidFill>
@@ -1178,11 +1178,11 @@
               </a:rPr>
               <a:t>start_step=cellbender</a:t>
             </a:r>
-            <a:endParaRPr lang="ko-KR" sz="1300"/>
-          </a:p>
-          <a:p>
-            <a:r>
-              <a:rPr lang="ko-KR" sz="1300">
+            <a:endParaRPr lang="en-US" sz="1300"/>
+          </a:p>
+          <a:p>
+            <a:r>
+              <a:rPr lang="en-US" sz="1300">
                 <a:solidFill>
                   <a:srgbClr val="374151"/>
                 </a:solidFill>
@@ -1191,7 +1191,7 @@
               </a:rPr>
               <a:t>10x raw feature matrix H5</a:t>
             </a:r>
-            <a:endParaRPr lang="ko-KR" sz="1300"/>
+            <a:endParaRPr lang="en-US" sz="1300"/>
           </a:p>
         </p:txBody>
       </p:sp>
@@ -1290,7 +1290,7 @@
           <a:lstStyle/>
           <a:p>
             <a:r>
-              <a:rPr lang="ko-KR" sz="1300" b="1">
+              <a:rPr lang="en-US" sz="1300" b="1">
                 <a:solidFill>
                   <a:srgbClr val="0F766E"/>
                 </a:solidFill>
@@ -1299,11 +1299,11 @@
               </a:rPr>
               <a:t>02</a:t>
             </a:r>
-            <a:endParaRPr lang="ko-KR" sz="1300"/>
-          </a:p>
-          <a:p>
-            <a:r>
-              <a:rPr lang="ko-KR" sz="1600" b="1">
+            <a:endParaRPr lang="en-US" sz="1300"/>
+          </a:p>
+          <a:p>
+            <a:r>
+              <a:rPr lang="en-US" sz="1600" b="1">
                 <a:solidFill>
                   <a:srgbClr val="111827"/>
                 </a:solidFill>
@@ -1312,11 +1312,11 @@
               </a:rPr>
               <a:t>Remove Background</a:t>
             </a:r>
-            <a:endParaRPr lang="ko-KR" sz="1600"/>
-          </a:p>
-          <a:p>
-            <a:r>
-              <a:rPr lang="ko-KR" sz="1300">
+            <a:endParaRPr lang="en-US" sz="1600"/>
+          </a:p>
+          <a:p>
+            <a:r>
+              <a:rPr lang="en-US" sz="1300">
                 <a:solidFill>
                   <a:srgbClr val="374151"/>
                 </a:solidFill>
@@ -1325,11 +1325,11 @@
               </a:rPr>
               <a:t>{sample}.cellbender_cleaned.h5</a:t>
             </a:r>
-            <a:endParaRPr lang="ko-KR" sz="1300"/>
-          </a:p>
-          <a:p>
-            <a:r>
-              <a:rPr lang="ko-KR" sz="1300">
+            <a:endParaRPr lang="en-US" sz="1300"/>
+          </a:p>
+          <a:p>
+            <a:r>
+              <a:rPr lang="en-US" sz="1300">
                 <a:solidFill>
                   <a:srgbClr val="374151"/>
                 </a:solidFill>
@@ -1338,7 +1338,7 @@
               </a:rPr>
               <a:t>background-corrected count matrix</a:t>
             </a:r>
-            <a:endParaRPr lang="ko-KR" sz="1300"/>
+            <a:endParaRPr lang="en-US" sz="1300"/>
           </a:p>
         </p:txBody>
       </p:sp>
@@ -1392,7 +1392,7 @@
           <a:lstStyle/>
           <a:p>
             <a:r>
-              <a:rPr lang="ko-KR" sz="1200" b="1">
+              <a:rPr lang="en-US" sz="1200" b="1">
                 <a:solidFill>
                   <a:srgbClr val="374151"/>
                 </a:solidFill>
@@ -1401,7 +1401,7 @@
               </a:rPr>
               <a:t>Scanpy</a:t>
             </a:r>
-            <a:endParaRPr lang="ko-KR" sz="1200"/>
+            <a:endParaRPr lang="en-US" sz="1200"/>
           </a:p>
         </p:txBody>
       </p:sp>
@@ -1478,7 +1478,7 @@
           <a:lstStyle/>
           <a:p>
             <a:r>
-              <a:rPr lang="ko-KR" sz="1600" b="1">
+              <a:rPr lang="en-US" sz="1600" b="1">
                 <a:solidFill>
                   <a:srgbClr val="111827"/>
                 </a:solidFill>
@@ -1487,11 +1487,11 @@
               </a:rPr>
               <a:t>Optional start: cellbender_h5</a:t>
             </a:r>
-            <a:endParaRPr lang="ko-KR" sz="1600"/>
-          </a:p>
-          <a:p>
-            <a:r>
-              <a:rPr lang="ko-KR" sz="1300">
+            <a:endParaRPr lang="en-US" sz="1600"/>
+          </a:p>
+          <a:p>
+            <a:r>
+              <a:rPr lang="en-US" sz="1300">
                 <a:solidFill>
                   <a:srgbClr val="374151"/>
                 </a:solidFill>
@@ -1500,11 +1500,11 @@
               </a:rPr>
               <a:t>start_step=qc</a:t>
             </a:r>
-            <a:endParaRPr lang="ko-KR" sz="1300"/>
-          </a:p>
-          <a:p>
-            <a:r>
-              <a:rPr lang="ko-KR" sz="1300">
+            <a:endParaRPr lang="en-US" sz="1300"/>
+          </a:p>
+          <a:p>
+            <a:r>
+              <a:rPr lang="en-US" sz="1300">
                 <a:solidFill>
                   <a:srgbClr val="374151"/>
                 </a:solidFill>
@@ -1513,7 +1513,7 @@
               </a:rPr>
               <a:t>CellBender cleaned H5</a:t>
             </a:r>
-            <a:endParaRPr lang="ko-KR" sz="1300"/>
+            <a:endParaRPr lang="en-US" sz="1300"/>
           </a:p>
         </p:txBody>
       </p:sp>
@@ -1612,7 +1612,7 @@
           <a:lstStyle/>
           <a:p>
             <a:r>
-              <a:rPr lang="ko-KR" sz="1300" b="1">
+              <a:rPr lang="en-US" sz="1300" b="1">
                 <a:solidFill>
                   <a:srgbClr val="0F766E"/>
                 </a:solidFill>
@@ -1621,11 +1621,11 @@
               </a:rPr>
               <a:t>03</a:t>
             </a:r>
-            <a:endParaRPr lang="ko-KR" sz="1300"/>
-          </a:p>
-          <a:p>
-            <a:r>
-              <a:rPr lang="ko-KR" sz="1600" b="1">
+            <a:endParaRPr lang="en-US" sz="1300"/>
+          </a:p>
+          <a:p>
+            <a:r>
+              <a:rPr lang="en-US" sz="1600" b="1">
                 <a:solidFill>
                   <a:srgbClr val="111827"/>
                 </a:solidFill>
@@ -1634,11 +1634,11 @@
               </a:rPr>
               <a:t>Scanpy QC for SOLO</a:t>
             </a:r>
-            <a:endParaRPr lang="ko-KR" sz="1600"/>
-          </a:p>
-          <a:p>
-            <a:r>
-              <a:rPr lang="ko-KR" sz="1300">
+            <a:endParaRPr lang="en-US" sz="1600"/>
+          </a:p>
+          <a:p>
+            <a:r>
+              <a:rPr lang="en-US" sz="1300">
                 <a:solidFill>
                   <a:srgbClr val="374151"/>
                 </a:solidFill>
@@ -1647,11 +1647,11 @@
               </a:rPr>
               <a:t>Remove pct_counts_mt &gt;= 20</a:t>
             </a:r>
-            <a:endParaRPr lang="ko-KR" sz="1300"/>
-          </a:p>
-          <a:p>
-            <a:r>
-              <a:rPr lang="ko-KR" sz="1300">
+            <a:endParaRPr lang="en-US" sz="1300"/>
+          </a:p>
+          <a:p>
+            <a:r>
+              <a:rPr lang="en-US" sz="1300">
                 <a:solidFill>
                   <a:srgbClr val="374151"/>
                 </a:solidFill>
@@ -1660,11 +1660,11 @@
               </a:rPr>
               <a:t>min_genes, min_counts, min_cells</a:t>
             </a:r>
-            <a:endParaRPr lang="ko-KR" sz="1300"/>
-          </a:p>
-          <a:p>
-            <a:r>
-              <a:rPr lang="ko-KR" sz="1300">
+            <a:endParaRPr lang="en-US" sz="1300"/>
+          </a:p>
+          <a:p>
+            <a:r>
+              <a:rPr lang="en-US" sz="1300">
                 <a:solidFill>
                   <a:srgbClr val="374151"/>
                 </a:solidFill>
@@ -1673,7 +1673,7 @@
               </a:rPr>
               <a:t>full.h5ad + hvg2000.h5ad + QC CSV</a:t>
             </a:r>
-            <a:endParaRPr lang="ko-KR" sz="1300"/>
+            <a:endParaRPr lang="en-US" sz="1300"/>
           </a:p>
         </p:txBody>
       </p:sp>
@@ -1727,7 +1727,7 @@
           <a:lstStyle/>
           <a:p>
             <a:r>
-              <a:rPr lang="ko-KR" sz="1200" b="1">
+              <a:rPr lang="en-US" sz="1200" b="1">
                 <a:solidFill>
                   <a:srgbClr val="374151"/>
                 </a:solidFill>
@@ -1736,7 +1736,7 @@
               </a:rPr>
               <a:t>SOLO</a:t>
             </a:r>
-            <a:endParaRPr lang="ko-KR" sz="1200"/>
+            <a:endParaRPr lang="en-US" sz="1200"/>
           </a:p>
         </p:txBody>
       </p:sp>
@@ -1834,7 +1834,7 @@
           <a:lstStyle/>
           <a:p>
             <a:r>
-              <a:rPr lang="ko-KR" sz="1300" b="1">
+              <a:rPr lang="en-US" sz="1300" b="1">
                 <a:solidFill>
                   <a:srgbClr val="0F766E"/>
                 </a:solidFill>
@@ -1843,11 +1843,11 @@
               </a:rPr>
               <a:t>04</a:t>
             </a:r>
-            <a:endParaRPr lang="ko-KR" sz="1300"/>
-          </a:p>
-          <a:p>
-            <a:r>
-              <a:rPr lang="ko-KR" sz="1600" b="1">
+            <a:endParaRPr lang="en-US" sz="1300"/>
+          </a:p>
+          <a:p>
+            <a:r>
+              <a:rPr lang="en-US" sz="1600" b="1">
                 <a:solidFill>
                   <a:srgbClr val="111827"/>
                 </a:solidFill>
@@ -1856,11 +1856,11 @@
               </a:rPr>
               <a:t>SOLO Doublet Scoring</a:t>
             </a:r>
-            <a:endParaRPr lang="ko-KR" sz="1600"/>
-          </a:p>
-          <a:p>
-            <a:r>
-              <a:rPr lang="ko-KR" sz="1300">
+            <a:endParaRPr lang="en-US" sz="1600"/>
+          </a:p>
+          <a:p>
+            <a:r>
+              <a:rPr lang="en-US" sz="1300">
                 <a:solidFill>
                   <a:srgbClr val="374151"/>
                 </a:solidFill>
@@ -1869,11 +1869,11 @@
               </a:rPr>
               <a:t>{sample}.solo/soloed.h5ad</a:t>
             </a:r>
-            <a:endParaRPr lang="ko-KR" sz="1300"/>
-          </a:p>
-          <a:p>
-            <a:r>
-              <a:rPr lang="ko-KR" sz="1300">
+            <a:endParaRPr lang="en-US" sz="1300"/>
+          </a:p>
+          <a:p>
+            <a:r>
+              <a:rPr lang="en-US" sz="1300">
                 <a:solidFill>
                   <a:srgbClr val="374151"/>
                 </a:solidFill>
@@ -1882,7 +1882,7 @@
               </a:rPr>
               <a:t>doublet scores and labels</a:t>
             </a:r>
-            <a:endParaRPr lang="ko-KR" sz="1300"/>
+            <a:endParaRPr lang="en-US" sz="1300"/>
           </a:p>
         </p:txBody>
       </p:sp>
@@ -1958,7 +1958,7 @@
           <a:lstStyle/>
           <a:p>
             <a:r>
-              <a:rPr lang="ko-KR" sz="1200" b="1">
+              <a:rPr lang="en-US" sz="1200" b="1">
                 <a:solidFill>
                   <a:srgbClr val="374151"/>
                 </a:solidFill>
@@ -1967,7 +1967,7 @@
               </a:rPr>
               <a:t>filter_singlets</a:t>
             </a:r>
-            <a:endParaRPr lang="ko-KR" sz="1200"/>
+            <a:endParaRPr lang="en-US" sz="1200"/>
           </a:p>
         </p:txBody>
       </p:sp>
@@ -2087,7 +2087,7 @@
           <a:lstStyle/>
           <a:p>
             <a:r>
-              <a:rPr lang="ko-KR" sz="1300" b="1">
+              <a:rPr lang="en-US" sz="1300" b="1">
                 <a:solidFill>
                   <a:srgbClr val="0F766E"/>
                 </a:solidFill>
@@ -2096,11 +2096,11 @@
               </a:rPr>
               <a:t>05</a:t>
             </a:r>
-            <a:endParaRPr lang="ko-KR" sz="1300"/>
-          </a:p>
-          <a:p>
-            <a:r>
-              <a:rPr lang="ko-KR" sz="1600" b="1">
+            <a:endParaRPr lang="en-US" sz="1300"/>
+          </a:p>
+          <a:p>
+            <a:r>
+              <a:rPr lang="en-US" sz="1600" b="1">
                 <a:solidFill>
                   <a:srgbClr val="111827"/>
                 </a:solidFill>
@@ -2109,11 +2109,11 @@
               </a:rPr>
               <a:t>Filter SOLO Singlets</a:t>
             </a:r>
-            <a:endParaRPr lang="ko-KR" sz="1600"/>
-          </a:p>
-          <a:p>
-            <a:r>
-              <a:rPr lang="ko-KR" sz="1300">
+            <a:endParaRPr lang="en-US" sz="1600"/>
+          </a:p>
+          <a:p>
+            <a:r>
+              <a:rPr lang="en-US" sz="1300">
                 <a:solidFill>
                   <a:srgbClr val="374151"/>
                 </a:solidFill>
@@ -2122,11 +2122,11 @@
               </a:rPr>
               <a:t>annotated full + singlet-only H5AD</a:t>
             </a:r>
-            <a:endParaRPr lang="ko-KR" sz="1300"/>
-          </a:p>
-          <a:p>
-            <a:r>
-              <a:rPr lang="ko-KR" sz="1300">
+            <a:endParaRPr lang="en-US" sz="1300"/>
+          </a:p>
+          <a:p>
+            <a:r>
+              <a:rPr lang="en-US" sz="1300">
                 <a:solidFill>
                   <a:srgbClr val="374151"/>
                 </a:solidFill>
@@ -2135,7 +2135,7 @@
               </a:rPr>
               <a:t>SOLO labels, scores, doublet barcodes</a:t>
             </a:r>
-            <a:endParaRPr lang="ko-KR" sz="1300"/>
+            <a:endParaRPr lang="en-US" sz="1300"/>
           </a:p>
         </p:txBody>
       </p:sp>
@@ -2211,7 +2211,7 @@
           <a:lstStyle/>
           <a:p>
             <a:r>
-              <a:rPr lang="ko-KR" sz="1600" b="1">
+              <a:rPr lang="en-US" sz="1600" b="1">
                 <a:solidFill>
                   <a:srgbClr val="111827"/>
                 </a:solidFill>
@@ -2220,11 +2220,11 @@
               </a:rPr>
               <a:t>Final Cell-level H5ADs</a:t>
             </a:r>
-            <a:endParaRPr lang="ko-KR" sz="1600"/>
-          </a:p>
-          <a:p>
-            <a:r>
-              <a:rPr lang="ko-KR" sz="1300">
+            <a:endParaRPr lang="en-US" sz="1600"/>
+          </a:p>
+          <a:p>
+            <a:r>
+              <a:rPr lang="en-US" sz="1300">
                 <a:solidFill>
                   <a:srgbClr val="374151"/>
                 </a:solidFill>
@@ -2233,11 +2233,11 @@
               </a:rPr>
               <a:t>{sample}_qc_solo_annotated_full.h5ad</a:t>
             </a:r>
-            <a:endParaRPr lang="ko-KR" sz="1300"/>
-          </a:p>
-          <a:p>
-            <a:r>
-              <a:rPr lang="ko-KR" sz="1300">
+            <a:endParaRPr lang="en-US" sz="1300"/>
+          </a:p>
+          <a:p>
+            <a:r>
+              <a:rPr lang="en-US" sz="1300">
                 <a:solidFill>
                   <a:srgbClr val="374151"/>
                 </a:solidFill>
@@ -2246,7 +2246,7 @@
               </a:rPr>
               <a:t>{sample}_qc_solo_singlets_full.h5ad</a:t>
             </a:r>
-            <a:endParaRPr lang="ko-KR" sz="1300"/>
+            <a:endParaRPr lang="en-US" sz="1300"/>
           </a:p>
         </p:txBody>
       </p:sp>
@@ -2366,7 +2366,7 @@
           <a:lstStyle/>
           <a:p>
             <a:r>
-              <a:rPr lang="ko-KR" sz="1200" b="1">
+              <a:rPr lang="en-US" sz="1200" b="1">
                 <a:solidFill>
                   <a:srgbClr val="374151"/>
                 </a:solidFill>
@@ -2375,7 +2375,7 @@
               </a:rPr>
               <a:t>merge_qc</a:t>
             </a:r>
-            <a:endParaRPr lang="ko-KR" sz="1200"/>
+            <a:endParaRPr lang="en-US" sz="1200"/>
           </a:p>
         </p:txBody>
       </p:sp>
@@ -2451,7 +2451,7 @@
           <a:lstStyle/>
           <a:p>
             <a:r>
-              <a:rPr lang="ko-KR" sz="1300" b="1">
+              <a:rPr lang="en-US" sz="1300" b="1">
                 <a:solidFill>
                   <a:srgbClr val="0F766E"/>
                 </a:solidFill>
@@ -2460,11 +2460,11 @@
               </a:rPr>
               <a:t>06</a:t>
             </a:r>
-            <a:endParaRPr lang="ko-KR" sz="1300"/>
-          </a:p>
-          <a:p>
-            <a:r>
-              <a:rPr lang="ko-KR" sz="1600" b="1">
+            <a:endParaRPr lang="en-US" sz="1300"/>
+          </a:p>
+          <a:p>
+            <a:r>
+              <a:rPr lang="en-US" sz="1600" b="1">
                 <a:solidFill>
                   <a:srgbClr val="111827"/>
                 </a:solidFill>
@@ -2473,11 +2473,11 @@
               </a:rPr>
               <a:t>QC Summary Merge</a:t>
             </a:r>
-            <a:endParaRPr lang="ko-KR" sz="1600"/>
-          </a:p>
-          <a:p>
-            <a:r>
-              <a:rPr lang="ko-KR" sz="1300">
+            <a:endParaRPr lang="en-US" sz="1600"/>
+          </a:p>
+          <a:p>
+            <a:r>
+              <a:rPr lang="en-US" sz="1300">
                 <a:solidFill>
                   <a:srgbClr val="374151"/>
                 </a:solidFill>
@@ -2486,7 +2486,7 @@
               </a:rPr>
               <a:t>QC metrics + SOLO summary</a:t>
             </a:r>
-            <a:endParaRPr lang="ko-KR" sz="1300"/>
+            <a:endParaRPr lang="en-US" sz="1300"/>
           </a:p>
         </p:txBody>
       </p:sp>
@@ -2584,7 +2584,7 @@
           <a:lstStyle/>
           <a:p>
             <a:r>
-              <a:rPr lang="ko-KR" sz="1600" b="1">
+              <a:rPr lang="en-US" sz="1600" b="1">
                 <a:solidFill>
                   <a:srgbClr val="111827"/>
                 </a:solidFill>
@@ -2593,11 +2593,11 @@
               </a:rPr>
               <a:t>Final QC Table</a:t>
             </a:r>
-            <a:endParaRPr lang="ko-KR" sz="1600"/>
-          </a:p>
-          <a:p>
-            <a:r>
-              <a:rPr lang="ko-KR" sz="1300">
+            <a:endParaRPr lang="en-US" sz="1600"/>
+          </a:p>
+          <a:p>
+            <a:r>
+              <a:rPr lang="en-US" sz="1300">
                 <a:solidFill>
                   <a:srgbClr val="374151"/>
                 </a:solidFill>
@@ -2606,7 +2606,7 @@
               </a:rPr>
               <a:t>scrnaseq_qc_summary.csv</a:t>
             </a:r>
-            <a:endParaRPr lang="ko-KR" sz="1300"/>
+            <a:endParaRPr lang="en-US" sz="1300"/>
           </a:p>
         </p:txBody>
       </p:sp>
@@ -2636,7 +2636,7 @@
           <a:lstStyle/>
           <a:p>
             <a:r>
-              <a:rPr lang="ko-KR" sz="1300">
+              <a:rPr lang="en-US" sz="1300">
                 <a:solidFill>
                   <a:srgbClr val="4B5563"/>
                 </a:solidFill>
@@ -2645,11 +2645,11 @@
               </a:rPr>
               <a:t>Configurable CSV start_step: cellranger, cellbender, or qc. Species is set by the user-supplied Cell Ranger transcriptome reference.</a:t>
             </a:r>
-            <a:endParaRPr lang="ko-KR" sz="1300"/>
-          </a:p>
-          <a:p>
-            <a:r>
-              <a:rPr lang="ko-KR" sz="1300">
+            <a:endParaRPr lang="en-US" sz="1300"/>
+          </a:p>
+          <a:p>
+            <a:r>
+              <a:rPr lang="en-US" sz="1300">
                 <a:solidFill>
                   <a:srgbClr val="4B5563"/>
                 </a:solidFill>
@@ -2658,7 +2658,7 @@
               </a:rPr>
               <a:t>Default QC: pct_counts_mt &lt; 20, min_genes=200, min_counts=500, min_cells_gene=5, HVG=2000.</a:t>
             </a:r>
-            <a:endParaRPr lang="ko-KR" sz="1300"/>
+            <a:endParaRPr lang="en-US" sz="1300"/>
           </a:p>
         </p:txBody>
       </p:sp>
@@ -2720,29 +2720,29 @@
           <a:lstStyle/>
           <a:p>
             <a:r>
-              <a:rPr lang="ko-KR" sz="2800" b="1">
+              <a:rPr lang="en-US" sz="2800" b="1">
                 <a:solidFill>
                   <a:srgbClr val="1F2937"/>
                 </a:solidFill>
                 <a:latin typeface="Arial"/>
                 <a:ea typeface="Malgun Gothic"/>
               </a:rPr>
-              <a:t>04 SOLO 이후 05와 06의 관계</a:t>
-            </a:r>
-            <a:endParaRPr lang="ko-KR" sz="2800"/>
-          </a:p>
-          <a:p>
-            <a:r>
-              <a:rPr lang="ko-KR" sz="1600">
+              <a:t>How 05 and 06 relate after 04 SOLO</a:t>
+            </a:r>
+            <a:endParaRPr lang="en-US" sz="2800"/>
+          </a:p>
+          <a:p>
+            <a:r>
+              <a:rPr lang="en-US" sz="1600">
                 <a:solidFill>
                   <a:srgbClr val="4B5563"/>
                 </a:solidFill>
                 <a:latin typeface="Arial"/>
                 <a:ea typeface="Malgun Gothic"/>
               </a:rPr>
-              <a:t>04는 doublet 판정 결과를 만들고, 05는 그 결과로 h5ad를 필터링하며, 06은 CSV 요약만 합칩니다.</a:t>
-            </a:r>
-            <a:endParaRPr lang="ko-KR" sz="1600"/>
+              <a:t>04 produces the doublet calls, 05 filters the h5ad with them, and 06 only merges the CSV summaries.</a:t>
+            </a:r>
+            <a:endParaRPr lang="en-US" sz="1600"/>
           </a:p>
         </p:txBody>
       </p:sp>
@@ -2818,7 +2818,7 @@
           <a:lstStyle/>
           <a:p>
             <a:r>
-              <a:rPr lang="ko-KR" sz="1300" b="1">
+              <a:rPr lang="en-US" sz="1300" b="1">
                 <a:solidFill>
                   <a:srgbClr val="0F766E"/>
                 </a:solidFill>
@@ -2827,11 +2827,11 @@
               </a:rPr>
               <a:t>03 output A</a:t>
             </a:r>
-            <a:endParaRPr lang="ko-KR" sz="1300"/>
-          </a:p>
-          <a:p>
-            <a:r>
-              <a:rPr lang="ko-KR" sz="2000" b="1">
+            <a:endParaRPr lang="en-US" sz="1300"/>
+          </a:p>
+          <a:p>
+            <a:r>
+              <a:rPr lang="en-US" sz="2000" b="1">
                 <a:solidFill>
                   <a:srgbClr val="111827"/>
                 </a:solidFill>
@@ -2840,11 +2840,11 @@
               </a:rPr>
               <a:t>Full QC H5AD</a:t>
             </a:r>
-            <a:endParaRPr lang="ko-KR" sz="2000"/>
-          </a:p>
-          <a:p>
-            <a:r>
-              <a:rPr lang="ko-KR" sz="1400">
+            <a:endParaRPr lang="en-US" sz="2000"/>
+          </a:p>
+          <a:p>
+            <a:r>
+              <a:rPr lang="en-US" sz="1400">
                 <a:solidFill>
                   <a:srgbClr val="374151"/>
                 </a:solidFill>
@@ -2853,20 +2853,20 @@
               </a:rPr>
               <a:t>{sample}_qc_full.h5ad</a:t>
             </a:r>
-            <a:endParaRPr lang="ko-KR" sz="1400"/>
-          </a:p>
-          <a:p>
-            <a:r>
-              <a:rPr lang="ko-KR" sz="1300">
-                <a:solidFill>
-                  <a:srgbClr val="374151"/>
-                </a:solidFill>
-                <a:latin typeface="Arial"/>
-                <a:ea typeface="Malgun Gothic"/>
-              </a:rPr>
-              <a:t>미토콘드리아/유전자/카운트 QC는 통과했지만 doublet은 아직 제거되지 않음</a:t>
-            </a:r>
-            <a:endParaRPr lang="ko-KR" sz="1300"/>
+            <a:endParaRPr lang="en-US" sz="1400"/>
+          </a:p>
+          <a:p>
+            <a:r>
+              <a:rPr lang="en-US" sz="1300">
+                <a:solidFill>
+                  <a:srgbClr val="374151"/>
+                </a:solidFill>
+                <a:latin typeface="Arial"/>
+                <a:ea typeface="Malgun Gothic"/>
+              </a:rPr>
+              <a:t>Passed mitochondrial/gene/count QC; doublets not removed yet</a:t>
+            </a:r>
+            <a:endParaRPr lang="en-US" sz="1300"/>
           </a:p>
         </p:txBody>
       </p:sp>
@@ -2942,7 +2942,7 @@
           <a:lstStyle/>
           <a:p>
             <a:r>
-              <a:rPr lang="ko-KR" sz="1300" b="1">
+              <a:rPr lang="en-US" sz="1300" b="1">
                 <a:solidFill>
                   <a:srgbClr val="0F766E"/>
                 </a:solidFill>
@@ -2951,11 +2951,11 @@
               </a:rPr>
               <a:t>03 output B</a:t>
             </a:r>
-            <a:endParaRPr lang="ko-KR" sz="1300"/>
-          </a:p>
-          <a:p>
-            <a:r>
-              <a:rPr lang="ko-KR" sz="2000" b="1">
+            <a:endParaRPr lang="en-US" sz="1300"/>
+          </a:p>
+          <a:p>
+            <a:r>
+              <a:rPr lang="en-US" sz="2000" b="1">
                 <a:solidFill>
                   <a:srgbClr val="111827"/>
                 </a:solidFill>
@@ -2964,11 +2964,11 @@
               </a:rPr>
               <a:t>HVG H5AD for SOLO</a:t>
             </a:r>
-            <a:endParaRPr lang="ko-KR" sz="2000"/>
-          </a:p>
-          <a:p>
-            <a:r>
-              <a:rPr lang="ko-KR" sz="1400">
+            <a:endParaRPr lang="en-US" sz="2000"/>
+          </a:p>
+          <a:p>
+            <a:r>
+              <a:rPr lang="en-US" sz="1400">
                 <a:solidFill>
                   <a:srgbClr val="374151"/>
                 </a:solidFill>
@@ -2977,20 +2977,20 @@
               </a:rPr>
               <a:t>{sample}_qc_hvg2000.h5ad</a:t>
             </a:r>
-            <a:endParaRPr lang="ko-KR" sz="1400"/>
-          </a:p>
-          <a:p>
-            <a:r>
-              <a:rPr lang="ko-KR" sz="1300">
-                <a:solidFill>
-                  <a:srgbClr val="374151"/>
-                </a:solidFill>
-                <a:latin typeface="Arial"/>
-                <a:ea typeface="Malgun Gothic"/>
-              </a:rPr>
-              <a:t>SOLO 학습/판정용 HVG subset</a:t>
-            </a:r>
-            <a:endParaRPr lang="ko-KR" sz="1300"/>
+            <a:endParaRPr lang="en-US" sz="1400"/>
+          </a:p>
+          <a:p>
+            <a:r>
+              <a:rPr lang="en-US" sz="1300">
+                <a:solidFill>
+                  <a:srgbClr val="374151"/>
+                </a:solidFill>
+                <a:latin typeface="Arial"/>
+                <a:ea typeface="Malgun Gothic"/>
+              </a:rPr>
+              <a:t>HVG subset for SOLO training/calling</a:t>
+            </a:r>
+            <a:endParaRPr lang="en-US" sz="1300"/>
           </a:p>
         </p:txBody>
       </p:sp>
@@ -3066,7 +3066,7 @@
           <a:lstStyle/>
           <a:p>
             <a:r>
-              <a:rPr lang="ko-KR" sz="1300" b="1">
+              <a:rPr lang="en-US" sz="1300" b="1">
                 <a:solidFill>
                   <a:srgbClr val="0F766E"/>
                 </a:solidFill>
@@ -3075,11 +3075,11 @@
               </a:rPr>
               <a:t>04</a:t>
             </a:r>
-            <a:endParaRPr lang="ko-KR" sz="1300"/>
-          </a:p>
-          <a:p>
-            <a:r>
-              <a:rPr lang="ko-KR" sz="2000" b="1">
+            <a:endParaRPr lang="en-US" sz="1300"/>
+          </a:p>
+          <a:p>
+            <a:r>
+              <a:rPr lang="en-US" sz="2000" b="1">
                 <a:solidFill>
                   <a:srgbClr val="111827"/>
                 </a:solidFill>
@@ -3088,11 +3088,11 @@
               </a:rPr>
               <a:t>SOLO Doublet Scoring</a:t>
             </a:r>
-            <a:endParaRPr lang="ko-KR" sz="2000"/>
-          </a:p>
-          <a:p>
-            <a:r>
-              <a:rPr lang="ko-KR" sz="1400">
+            <a:endParaRPr lang="en-US" sz="2000"/>
+          </a:p>
+          <a:p>
+            <a:r>
+              <a:rPr lang="en-US" sz="1400">
                 <a:solidFill>
                   <a:srgbClr val="374151"/>
                 </a:solidFill>
@@ -3101,33 +3101,33 @@
               </a:rPr>
               <a:t>{sample}.solo/soloed.h5ad</a:t>
             </a:r>
-            <a:endParaRPr lang="ko-KR" sz="1400"/>
-          </a:p>
-          <a:p>
-            <a:r>
-              <a:rPr lang="ko-KR" sz="1300">
-                <a:solidFill>
-                  <a:srgbClr val="374151"/>
-                </a:solidFill>
-                <a:latin typeface="Arial"/>
-                <a:ea typeface="Malgun Gothic"/>
-              </a:rPr>
-              <a:t>각 barcode에 singlet/doublet label과 score를 부여</a:t>
-            </a:r>
-            <a:endParaRPr lang="ko-KR" sz="1300"/>
-          </a:p>
-          <a:p>
-            <a:r>
-              <a:rPr lang="ko-KR" sz="1300">
-                <a:solidFill>
-                  <a:srgbClr val="374151"/>
-                </a:solidFill>
-                <a:latin typeface="Arial"/>
-                <a:ea typeface="Malgun Gothic"/>
-              </a:rPr>
-              <a:t>이 파일은 최종 full-gene matrix가 아니라 판정 결과에 가까움</a:t>
-            </a:r>
-            <a:endParaRPr lang="ko-KR" sz="1300"/>
+            <a:endParaRPr lang="en-US" sz="1400"/>
+          </a:p>
+          <a:p>
+            <a:r>
+              <a:rPr lang="en-US" sz="1300">
+                <a:solidFill>
+                  <a:srgbClr val="374151"/>
+                </a:solidFill>
+                <a:latin typeface="Arial"/>
+                <a:ea typeface="Malgun Gothic"/>
+              </a:rPr>
+              <a:t>Assigns a singlet/doublet label and score to each barcode</a:t>
+            </a:r>
+            <a:endParaRPr lang="en-US" sz="1300"/>
+          </a:p>
+          <a:p>
+            <a:r>
+              <a:rPr lang="en-US" sz="1300">
+                <a:solidFill>
+                  <a:srgbClr val="374151"/>
+                </a:solidFill>
+                <a:latin typeface="Arial"/>
+                <a:ea typeface="Malgun Gothic"/>
+              </a:rPr>
+              <a:t>Closer to a set of calls than to the final full-gene matrix</a:t>
+            </a:r>
+            <a:endParaRPr lang="en-US" sz="1300"/>
           </a:p>
         </p:txBody>
       </p:sp>
@@ -3203,7 +3203,7 @@
           <a:lstStyle/>
           <a:p>
             <a:r>
-              <a:rPr lang="ko-KR" sz="1300" b="1">
+              <a:rPr lang="en-US" sz="1300" b="1">
                 <a:solidFill>
                   <a:srgbClr val="0F766E"/>
                 </a:solidFill>
@@ -3212,11 +3212,11 @@
               </a:rPr>
               <a:t>05</a:t>
             </a:r>
-            <a:endParaRPr lang="ko-KR" sz="1300"/>
-          </a:p>
-          <a:p>
-            <a:r>
-              <a:rPr lang="ko-KR" sz="2000" b="1">
+            <a:endParaRPr lang="en-US" sz="1300"/>
+          </a:p>
+          <a:p>
+            <a:r>
+              <a:rPr lang="en-US" sz="2000" b="1">
                 <a:solidFill>
                   <a:srgbClr val="111827"/>
                 </a:solidFill>
@@ -3225,11 +3225,11 @@
               </a:rPr>
               <a:t>Filter SOLO Singlets</a:t>
             </a:r>
-            <a:endParaRPr lang="ko-KR" sz="2000"/>
-          </a:p>
-          <a:p>
-            <a:r>
-              <a:rPr lang="ko-KR" sz="1400">
+            <a:endParaRPr lang="en-US" sz="2000"/>
+          </a:p>
+          <a:p>
+            <a:r>
+              <a:rPr lang="en-US" sz="1400">
                 <a:solidFill>
                   <a:srgbClr val="374151"/>
                 </a:solidFill>
@@ -3238,20 +3238,20 @@
               </a:rPr>
               <a:t>Full QC H5AD + SOLO labels</a:t>
             </a:r>
-            <a:endParaRPr lang="ko-KR" sz="1400"/>
-          </a:p>
-          <a:p>
-            <a:r>
-              <a:rPr lang="ko-KR" sz="1300">
-                <a:solidFill>
-                  <a:srgbClr val="374151"/>
-                </a:solidFill>
-                <a:latin typeface="Arial"/>
-                <a:ea typeface="Malgun Gothic"/>
-              </a:rPr>
-              <a:t>SOLO label을 붙인 full h5ad와 doublet 제거 후 singlet-only h5ad 생성</a:t>
-            </a:r>
-            <a:endParaRPr lang="ko-KR" sz="1300"/>
+            <a:endParaRPr lang="en-US" sz="1400"/>
+          </a:p>
+          <a:p>
+            <a:r>
+              <a:rPr lang="en-US" sz="1300">
+                <a:solidFill>
+                  <a:srgbClr val="374151"/>
+                </a:solidFill>
+                <a:latin typeface="Arial"/>
+                <a:ea typeface="Malgun Gothic"/>
+              </a:rPr>
+              <a:t>Writes the SOLO-labelled full h5ad and the singlet-only h5ad after doublet removal</a:t>
+            </a:r>
+            <a:endParaRPr lang="en-US" sz="1300"/>
           </a:p>
         </p:txBody>
       </p:sp>
@@ -3327,7 +3327,7 @@
           <a:lstStyle/>
           <a:p>
             <a:r>
-              <a:rPr lang="ko-KR" sz="1300" b="1">
+              <a:rPr lang="en-US" sz="1300" b="1">
                 <a:solidFill>
                   <a:srgbClr val="0F766E"/>
                 </a:solidFill>
@@ -3336,11 +3336,11 @@
               </a:rPr>
               <a:t>06</a:t>
             </a:r>
-            <a:endParaRPr lang="ko-KR" sz="1300"/>
-          </a:p>
-          <a:p>
-            <a:r>
-              <a:rPr lang="ko-KR" sz="2000" b="1">
+            <a:endParaRPr lang="en-US" sz="1300"/>
+          </a:p>
+          <a:p>
+            <a:r>
+              <a:rPr lang="en-US" sz="2000" b="1">
                 <a:solidFill>
                   <a:srgbClr val="111827"/>
                 </a:solidFill>
@@ -3349,11 +3349,11 @@
               </a:rPr>
               <a:t>QC Summary Merge</a:t>
             </a:r>
-            <a:endParaRPr lang="ko-KR" sz="2000"/>
-          </a:p>
-          <a:p>
-            <a:r>
-              <a:rPr lang="ko-KR" sz="1400">
+            <a:endParaRPr lang="en-US" sz="2000"/>
+          </a:p>
+          <a:p>
+            <a:r>
+              <a:rPr lang="en-US" sz="1400">
                 <a:solidFill>
                   <a:srgbClr val="374151"/>
                 </a:solidFill>
@@ -3362,20 +3362,20 @@
               </a:rPr>
               <a:t>scrnaseq_qc_summary.csv</a:t>
             </a:r>
-            <a:endParaRPr lang="ko-KR" sz="1400"/>
-          </a:p>
-          <a:p>
-            <a:r>
-              <a:rPr lang="ko-KR" sz="1300">
-                <a:solidFill>
-                  <a:srgbClr val="374151"/>
-                </a:solidFill>
-                <a:latin typeface="Arial"/>
-                <a:ea typeface="Malgun Gothic"/>
-              </a:rPr>
-              <a:t>03 QC metrics와 05 SOLO summary를 sample 단위로 합치는 reporting 단계</a:t>
-            </a:r>
-            <a:endParaRPr lang="ko-KR" sz="1300"/>
+            <a:endParaRPr lang="en-US" sz="1400"/>
+          </a:p>
+          <a:p>
+            <a:r>
+              <a:rPr lang="en-US" sz="1300">
+                <a:solidFill>
+                  <a:srgbClr val="374151"/>
+                </a:solidFill>
+                <a:latin typeface="Arial"/>
+                <a:ea typeface="Malgun Gothic"/>
+              </a:rPr>
+              <a:t>Reporting step that merges the 03 QC metrics and 05 SOLO summary per sample</a:t>
+            </a:r>
+            <a:endParaRPr lang="en-US" sz="1300"/>
           </a:p>
         </p:txBody>
       </p:sp>
@@ -3561,20 +3561,20 @@
           <a:lstStyle/>
           <a:p>
             <a:r>
-              <a:rPr lang="ko-KR" sz="1600" b="1">
+              <a:rPr lang="en-US" sz="1600" b="1">
                 <a:solidFill>
                   <a:srgbClr val="111827"/>
                 </a:solidFill>
                 <a:latin typeface="Arial"/>
                 <a:ea typeface="Malgun Gothic"/>
               </a:rPr>
-              <a:t>SOLO 주석 포함, doublet 제거 전 h5ad</a:t>
-            </a:r>
-            <a:endParaRPr lang="ko-KR" sz="1600"/>
-          </a:p>
-          <a:p>
-            <a:r>
-              <a:rPr lang="ko-KR" sz="1500">
+              <a:t>h5ad with SOLO annotations, before doublet removal</a:t>
+            </a:r>
+            <a:endParaRPr lang="en-US" sz="1600"/>
+          </a:p>
+          <a:p>
+            <a:r>
+              <a:rPr lang="en-US" sz="1500">
                 <a:solidFill>
                   <a:srgbClr val="374151"/>
                 </a:solidFill>
@@ -3583,33 +3583,33 @@
               </a:rPr>
               <a:t>{sample}_qc_solo_annotated_full.h5ad</a:t>
             </a:r>
-            <a:endParaRPr lang="ko-KR" sz="1500"/>
-          </a:p>
-          <a:p>
-            <a:r>
-              <a:rPr lang="ko-KR" sz="1300">
-                <a:solidFill>
-                  <a:srgbClr val="374151"/>
-                </a:solidFill>
-                <a:latin typeface="Arial"/>
-                <a:ea typeface="Malgun Gothic"/>
-              </a:rPr>
-              <a:t>저장 위치: results/{sample}/05_singlets/</a:t>
-            </a:r>
-            <a:endParaRPr lang="ko-KR" sz="1300"/>
-          </a:p>
-          <a:p>
-            <a:r>
-              <a:rPr lang="ko-KR" sz="1300">
-                <a:solidFill>
-                  <a:srgbClr val="374151"/>
-                </a:solidFill>
-                <a:latin typeface="Arial"/>
-                <a:ea typeface="Malgun Gothic"/>
-              </a:rPr>
-              <a:t>QC를 통과한 모든 cell을 유지하고 obs에 solo_is_doublet, solo_softmax_scores, solo_logit_scores를 추가합니다.</a:t>
-            </a:r>
-            <a:endParaRPr lang="ko-KR" sz="1300"/>
+            <a:endParaRPr lang="en-US" sz="1500"/>
+          </a:p>
+          <a:p>
+            <a:r>
+              <a:rPr lang="en-US" sz="1300">
+                <a:solidFill>
+                  <a:srgbClr val="374151"/>
+                </a:solidFill>
+                <a:latin typeface="Arial"/>
+                <a:ea typeface="Malgun Gothic"/>
+              </a:rPr>
+              <a:t>Location: results/{sample}/05_singlets/</a:t>
+            </a:r>
+            <a:endParaRPr lang="en-US" sz="1300"/>
+          </a:p>
+          <a:p>
+            <a:r>
+              <a:rPr lang="en-US" sz="1300">
+                <a:solidFill>
+                  <a:srgbClr val="374151"/>
+                </a:solidFill>
+                <a:latin typeface="Arial"/>
+                <a:ea typeface="Malgun Gothic"/>
+              </a:rPr>
+              <a:t>Keeps every QC-passed cell and adds solo_is_doublet, solo_softmax_scores and solo_logit_scores to obs.</a:t>
+            </a:r>
+            <a:endParaRPr lang="en-US" sz="1300"/>
           </a:p>
         </p:txBody>
       </p:sp>
@@ -3685,20 +3685,20 @@
           <a:lstStyle/>
           <a:p>
             <a:r>
-              <a:rPr lang="ko-KR" sz="1600" b="1">
+              <a:rPr lang="en-US" sz="1600" b="1">
                 <a:solidFill>
                   <a:srgbClr val="111827"/>
                 </a:solidFill>
                 <a:latin typeface="Arial"/>
                 <a:ea typeface="Malgun Gothic"/>
               </a:rPr>
-              <a:t>Doublet 제거 후 h5ad</a:t>
-            </a:r>
-            <a:endParaRPr lang="ko-KR" sz="1600"/>
-          </a:p>
-          <a:p>
-            <a:r>
-              <a:rPr lang="ko-KR" sz="1500">
+              <a:t>h5ad after doublet removal</a:t>
+            </a:r>
+            <a:endParaRPr lang="en-US" sz="1600"/>
+          </a:p>
+          <a:p>
+            <a:r>
+              <a:rPr lang="en-US" sz="1500">
                 <a:solidFill>
                   <a:srgbClr val="374151"/>
                 </a:solidFill>
@@ -3707,33 +3707,33 @@
               </a:rPr>
               <a:t>{sample}_qc_solo_singlets_full.h5ad</a:t>
             </a:r>
-            <a:endParaRPr lang="ko-KR" sz="1500"/>
-          </a:p>
-          <a:p>
-            <a:r>
-              <a:rPr lang="ko-KR" sz="1300">
-                <a:solidFill>
-                  <a:srgbClr val="374151"/>
-                </a:solidFill>
-                <a:latin typeface="Arial"/>
-                <a:ea typeface="Malgun Gothic"/>
-              </a:rPr>
-              <a:t>저장 위치: results/{sample}/05_singlets/</a:t>
-            </a:r>
-            <a:endParaRPr lang="ko-KR" sz="1300"/>
-          </a:p>
-          <a:p>
-            <a:r>
-              <a:rPr lang="ko-KR" sz="1300">
-                <a:solidFill>
-                  <a:srgbClr val="374151"/>
-                </a:solidFill>
-                <a:latin typeface="Arial"/>
-                <a:ea typeface="Malgun Gothic"/>
-              </a:rPr>
-              <a:t>SOLO에서 doublet으로 판정된 barcode를 제거한 최종 분석용 full-gene matrix입니다.</a:t>
-            </a:r>
-            <a:endParaRPr lang="ko-KR" sz="1300"/>
+            <a:endParaRPr lang="en-US" sz="1500"/>
+          </a:p>
+          <a:p>
+            <a:r>
+              <a:rPr lang="en-US" sz="1300">
+                <a:solidFill>
+                  <a:srgbClr val="374151"/>
+                </a:solidFill>
+                <a:latin typeface="Arial"/>
+                <a:ea typeface="Malgun Gothic"/>
+              </a:rPr>
+              <a:t>Location: results/{sample}/05_singlets/</a:t>
+            </a:r>
+            <a:endParaRPr lang="en-US" sz="1300"/>
+          </a:p>
+          <a:p>
+            <a:r>
+              <a:rPr lang="en-US" sz="1300">
+                <a:solidFill>
+                  <a:srgbClr val="374151"/>
+                </a:solidFill>
+                <a:latin typeface="Arial"/>
+                <a:ea typeface="Malgun Gothic"/>
+              </a:rPr>
+              <a:t>Final full-gene matrix for analysis, with barcodes called doublets by SOLO removed.</a:t>
+            </a:r>
+            <a:endParaRPr lang="en-US" sz="1300"/>
           </a:p>
         </p:txBody>
       </p:sp>
@@ -3763,29 +3763,29 @@
           <a:lstStyle/>
           <a:p>
             <a:r>
-              <a:rPr lang="ko-KR" sz="1600" b="1">
+              <a:rPr lang="en-US" sz="1600" b="1">
                 <a:solidFill>
                   <a:srgbClr val="0F766E"/>
                 </a:solidFill>
                 <a:latin typeface="Arial"/>
                 <a:ea typeface="Malgun Gothic"/>
               </a:rPr>
-              <a:t>현재 파이프라인은 기본 QC 후 full h5ad, SOLO annotated full h5ad, SOLO singlet-only h5ad를 모두 저장합니다.</a:t>
-            </a:r>
-            <a:endParaRPr lang="ko-KR" sz="1600"/>
-          </a:p>
-          <a:p>
-            <a:r>
-              <a:rPr lang="ko-KR" sz="1500">
-                <a:solidFill>
-                  <a:srgbClr val="374151"/>
-                </a:solidFill>
-                <a:latin typeface="Arial"/>
-                <a:ea typeface="Malgun Gothic"/>
-              </a:rPr>
-              <a:t>따라서 doublet 제거 전/후를 비교하거나, doublet 판정만 metadata로 유지한 분석을 따로 진행할 수 있습니다.</a:t>
-            </a:r>
-            <a:endParaRPr lang="ko-KR" sz="1500"/>
+              <a:t>The pipeline saves the full h5ad after basic QC, the SOLO-annotated full h5ad and the SOLO singlet-only h5ad.</a:t>
+            </a:r>
+            <a:endParaRPr lang="en-US" sz="1600"/>
+          </a:p>
+          <a:p>
+            <a:r>
+              <a:rPr lang="en-US" sz="1500">
+                <a:solidFill>
+                  <a:srgbClr val="374151"/>
+                </a:solidFill>
+                <a:latin typeface="Arial"/>
+                <a:ea typeface="Malgun Gothic"/>
+              </a:rPr>
+              <a:t>So you can compare before/after doublet removal, or keep the doublet calls only as metadata in a separate analysis.</a:t>
+            </a:r>
+            <a:endParaRPr lang="en-US" sz="1500"/>
           </a:p>
         </p:txBody>
       </p:sp>

</xml_diff>